<commit_message>
add bio comps module
</commit_message>
<xml_diff>
--- a/SALT_icons.pptx
+++ b/SALT_icons.pptx
@@ -9,6 +9,8 @@
     <p:sldId id="257" r:id="rId3"/>
     <p:sldId id="258" r:id="rId4"/>
     <p:sldId id="259" r:id="rId5"/>
+    <p:sldId id="260" r:id="rId6"/>
+    <p:sldId id="261" r:id="rId7"/>
   </p:sldIdLst>
   <p:sldSz cx="12192000" cy="6858000"/>
   <p:notesSz cx="6858000" cy="9144000"/>
@@ -107,6 +109,11 @@
       </a:defRPr>
     </a:lvl9pPr>
   </p:defaultTextStyle>
+  <p:extLst>
+    <p:ext uri="{EFAFB233-063F-42B5-8137-9DF3F51BA10A}">
+      <p15:sldGuideLst xmlns:p15="http://schemas.microsoft.com/office/powerpoint/2012/main"/>
+    </p:ext>
+  </p:extLst>
 </p:presentation>
 </file>
 
@@ -257,7 +264,7 @@
           <a:p>
             <a:fld id="{A52A0AC6-1FC2-46EF-B96C-23ED3DABE568}" type="datetimeFigureOut">
               <a:rPr lang="en-US" smtClean="0"/>
-              <a:t>10/8/2025</a:t>
+              <a:t>12/9/2025</a:t>
             </a:fld>
             <a:endParaRPr lang="en-US"/>
           </a:p>
@@ -455,7 +462,7 @@
           <a:p>
             <a:fld id="{A52A0AC6-1FC2-46EF-B96C-23ED3DABE568}" type="datetimeFigureOut">
               <a:rPr lang="en-US" smtClean="0"/>
-              <a:t>10/8/2025</a:t>
+              <a:t>12/9/2025</a:t>
             </a:fld>
             <a:endParaRPr lang="en-US"/>
           </a:p>
@@ -663,7 +670,7 @@
           <a:p>
             <a:fld id="{A52A0AC6-1FC2-46EF-B96C-23ED3DABE568}" type="datetimeFigureOut">
               <a:rPr lang="en-US" smtClean="0"/>
-              <a:t>10/8/2025</a:t>
+              <a:t>12/9/2025</a:t>
             </a:fld>
             <a:endParaRPr lang="en-US"/>
           </a:p>
@@ -861,7 +868,7 @@
           <a:p>
             <a:fld id="{A52A0AC6-1FC2-46EF-B96C-23ED3DABE568}" type="datetimeFigureOut">
               <a:rPr lang="en-US" smtClean="0"/>
-              <a:t>10/8/2025</a:t>
+              <a:t>12/9/2025</a:t>
             </a:fld>
             <a:endParaRPr lang="en-US"/>
           </a:p>
@@ -1136,7 +1143,7 @@
           <a:p>
             <a:fld id="{A52A0AC6-1FC2-46EF-B96C-23ED3DABE568}" type="datetimeFigureOut">
               <a:rPr lang="en-US" smtClean="0"/>
-              <a:t>10/8/2025</a:t>
+              <a:t>12/9/2025</a:t>
             </a:fld>
             <a:endParaRPr lang="en-US"/>
           </a:p>
@@ -1401,7 +1408,7 @@
           <a:p>
             <a:fld id="{A52A0AC6-1FC2-46EF-B96C-23ED3DABE568}" type="datetimeFigureOut">
               <a:rPr lang="en-US" smtClean="0"/>
-              <a:t>10/8/2025</a:t>
+              <a:t>12/9/2025</a:t>
             </a:fld>
             <a:endParaRPr lang="en-US"/>
           </a:p>
@@ -1813,7 +1820,7 @@
           <a:p>
             <a:fld id="{A52A0AC6-1FC2-46EF-B96C-23ED3DABE568}" type="datetimeFigureOut">
               <a:rPr lang="en-US" smtClean="0"/>
-              <a:t>10/8/2025</a:t>
+              <a:t>12/9/2025</a:t>
             </a:fld>
             <a:endParaRPr lang="en-US"/>
           </a:p>
@@ -1954,7 +1961,7 @@
           <a:p>
             <a:fld id="{A52A0AC6-1FC2-46EF-B96C-23ED3DABE568}" type="datetimeFigureOut">
               <a:rPr lang="en-US" smtClean="0"/>
-              <a:t>10/8/2025</a:t>
+              <a:t>12/9/2025</a:t>
             </a:fld>
             <a:endParaRPr lang="en-US"/>
           </a:p>
@@ -2067,7 +2074,7 @@
           <a:p>
             <a:fld id="{A52A0AC6-1FC2-46EF-B96C-23ED3DABE568}" type="datetimeFigureOut">
               <a:rPr lang="en-US" smtClean="0"/>
-              <a:t>10/8/2025</a:t>
+              <a:t>12/9/2025</a:t>
             </a:fld>
             <a:endParaRPr lang="en-US"/>
           </a:p>
@@ -2378,7 +2385,7 @@
           <a:p>
             <a:fld id="{A52A0AC6-1FC2-46EF-B96C-23ED3DABE568}" type="datetimeFigureOut">
               <a:rPr lang="en-US" smtClean="0"/>
-              <a:t>10/8/2025</a:t>
+              <a:t>12/9/2025</a:t>
             </a:fld>
             <a:endParaRPr lang="en-US"/>
           </a:p>
@@ -2666,7 +2673,7 @@
           <a:p>
             <a:fld id="{A52A0AC6-1FC2-46EF-B96C-23ED3DABE568}" type="datetimeFigureOut">
               <a:rPr lang="en-US" smtClean="0"/>
-              <a:t>10/8/2025</a:t>
+              <a:t>12/9/2025</a:t>
             </a:fld>
             <a:endParaRPr lang="en-US"/>
           </a:p>
@@ -2907,7 +2914,7 @@
           <a:p>
             <a:fld id="{A52A0AC6-1FC2-46EF-B96C-23ED3DABE568}" type="datetimeFigureOut">
               <a:rPr lang="en-US" smtClean="0"/>
-              <a:t>10/8/2025</a:t>
+              <a:t>12/9/2025</a:t>
             </a:fld>
             <a:endParaRPr lang="en-US"/>
           </a:p>
@@ -6688,6 +6695,544 @@
 </p:sld>
 </file>
 
+<file path=ppt/slides/slide5.xml><?xml version="1.0" encoding="utf-8"?>
+<p:sld xmlns:a="http://schemas.openxmlformats.org/drawingml/2006/main" xmlns:r="http://schemas.openxmlformats.org/officeDocument/2006/relationships" xmlns:p="http://schemas.openxmlformats.org/presentationml/2006/main">
+  <p:cSld>
+    <p:spTree>
+      <p:nvGrpSpPr>
+        <p:cNvPr id="1" name=""/>
+        <p:cNvGrpSpPr/>
+        <p:nvPr/>
+      </p:nvGrpSpPr>
+      <p:grpSpPr>
+        <a:xfrm>
+          <a:off x="0" y="0"/>
+          <a:ext cx="0" cy="0"/>
+          <a:chOff x="0" y="0"/>
+          <a:chExt cx="0" cy="0"/>
+        </a:xfrm>
+      </p:grpSpPr>
+      <p:cxnSp>
+        <p:nvCxnSpPr>
+          <p:cNvPr id="5" name="Straight Connector 4">
+            <a:extLst>
+              <a:ext uri="{FF2B5EF4-FFF2-40B4-BE49-F238E27FC236}">
+                <a16:creationId xmlns:a16="http://schemas.microsoft.com/office/drawing/2014/main" id="{00056AB4-D151-4B6B-893C-EF871DF79847}"/>
+              </a:ext>
+            </a:extLst>
+          </p:cNvPr>
+          <p:cNvCxnSpPr>
+            <a:cxnSpLocks/>
+          </p:cNvCxnSpPr>
+          <p:nvPr/>
+        </p:nvCxnSpPr>
+        <p:spPr>
+          <a:xfrm flipH="1" flipV="1">
+            <a:off x="3165987" y="1800225"/>
+            <a:ext cx="6009045" cy="2802196"/>
+          </a:xfrm>
+          <a:prstGeom prst="line">
+            <a:avLst/>
+          </a:prstGeom>
+          <a:ln w="44450">
+            <a:solidFill>
+              <a:schemeClr val="accent6">
+                <a:lumMod val="60000"/>
+                <a:lumOff val="40000"/>
+              </a:schemeClr>
+            </a:solidFill>
+            <a:prstDash val="sysDash"/>
+            <a:headEnd type="oval"/>
+            <a:tailEnd type="oval"/>
+          </a:ln>
+        </p:spPr>
+        <p:style>
+          <a:lnRef idx="1">
+            <a:schemeClr val="accent1"/>
+          </a:lnRef>
+          <a:fillRef idx="0">
+            <a:schemeClr val="accent1"/>
+          </a:fillRef>
+          <a:effectRef idx="0">
+            <a:schemeClr val="accent1"/>
+          </a:effectRef>
+          <a:fontRef idx="minor">
+            <a:schemeClr val="tx1"/>
+          </a:fontRef>
+        </p:style>
+      </p:cxnSp>
+      <p:cxnSp>
+        <p:nvCxnSpPr>
+          <p:cNvPr id="51" name="Straight Connector 50">
+            <a:extLst>
+              <a:ext uri="{FF2B5EF4-FFF2-40B4-BE49-F238E27FC236}">
+                <a16:creationId xmlns:a16="http://schemas.microsoft.com/office/drawing/2014/main" id="{5228FB99-1D64-4061-971C-C3DB85B3CD2B}"/>
+              </a:ext>
+            </a:extLst>
+          </p:cNvPr>
+          <p:cNvCxnSpPr>
+            <a:cxnSpLocks/>
+          </p:cNvCxnSpPr>
+          <p:nvPr/>
+        </p:nvCxnSpPr>
+        <p:spPr>
+          <a:xfrm flipH="1" flipV="1">
+            <a:off x="4188542" y="2645797"/>
+            <a:ext cx="4986491" cy="1956626"/>
+          </a:xfrm>
+          <a:prstGeom prst="line">
+            <a:avLst/>
+          </a:prstGeom>
+          <a:ln w="44450">
+            <a:solidFill>
+              <a:schemeClr val="accent6">
+                <a:lumMod val="60000"/>
+                <a:lumOff val="40000"/>
+              </a:schemeClr>
+            </a:solidFill>
+            <a:prstDash val="sysDash"/>
+            <a:headEnd type="oval"/>
+            <a:tailEnd type="oval"/>
+          </a:ln>
+        </p:spPr>
+        <p:style>
+          <a:lnRef idx="1">
+            <a:schemeClr val="accent1"/>
+          </a:lnRef>
+          <a:fillRef idx="0">
+            <a:schemeClr val="accent1"/>
+          </a:fillRef>
+          <a:effectRef idx="0">
+            <a:schemeClr val="accent1"/>
+          </a:effectRef>
+          <a:fontRef idx="minor">
+            <a:schemeClr val="tx1"/>
+          </a:fontRef>
+        </p:style>
+      </p:cxnSp>
+      <p:cxnSp>
+        <p:nvCxnSpPr>
+          <p:cNvPr id="53" name="Straight Connector 52">
+            <a:extLst>
+              <a:ext uri="{FF2B5EF4-FFF2-40B4-BE49-F238E27FC236}">
+                <a16:creationId xmlns:a16="http://schemas.microsoft.com/office/drawing/2014/main" id="{22D0A006-C730-4331-B8A7-E68445F4A1B4}"/>
+              </a:ext>
+            </a:extLst>
+          </p:cNvPr>
+          <p:cNvCxnSpPr>
+            <a:cxnSpLocks/>
+          </p:cNvCxnSpPr>
+          <p:nvPr/>
+        </p:nvCxnSpPr>
+        <p:spPr>
+          <a:xfrm flipH="1" flipV="1">
+            <a:off x="5388077" y="3383221"/>
+            <a:ext cx="3796790" cy="1219200"/>
+          </a:xfrm>
+          <a:prstGeom prst="line">
+            <a:avLst/>
+          </a:prstGeom>
+          <a:ln w="44450">
+            <a:solidFill>
+              <a:schemeClr val="accent6">
+                <a:lumMod val="60000"/>
+                <a:lumOff val="40000"/>
+              </a:schemeClr>
+            </a:solidFill>
+            <a:prstDash val="sysDash"/>
+            <a:headEnd type="oval"/>
+            <a:tailEnd type="oval"/>
+          </a:ln>
+        </p:spPr>
+        <p:style>
+          <a:lnRef idx="1">
+            <a:schemeClr val="accent1"/>
+          </a:lnRef>
+          <a:fillRef idx="0">
+            <a:schemeClr val="accent1"/>
+          </a:fillRef>
+          <a:effectRef idx="0">
+            <a:schemeClr val="accent1"/>
+          </a:effectRef>
+          <a:fontRef idx="minor">
+            <a:schemeClr val="tx1"/>
+          </a:fontRef>
+        </p:style>
+      </p:cxnSp>
+      <p:cxnSp>
+        <p:nvCxnSpPr>
+          <p:cNvPr id="56" name="Straight Connector 55">
+            <a:extLst>
+              <a:ext uri="{FF2B5EF4-FFF2-40B4-BE49-F238E27FC236}">
+                <a16:creationId xmlns:a16="http://schemas.microsoft.com/office/drawing/2014/main" id="{B23A6548-10CA-4F9E-B5A7-2677D92A4B70}"/>
+              </a:ext>
+            </a:extLst>
+          </p:cNvPr>
+          <p:cNvCxnSpPr>
+            <a:cxnSpLocks/>
+          </p:cNvCxnSpPr>
+          <p:nvPr/>
+        </p:nvCxnSpPr>
+        <p:spPr>
+          <a:xfrm flipH="1" flipV="1">
+            <a:off x="6420465" y="3938739"/>
+            <a:ext cx="2764400" cy="663682"/>
+          </a:xfrm>
+          <a:prstGeom prst="line">
+            <a:avLst/>
+          </a:prstGeom>
+          <a:ln w="44450">
+            <a:solidFill>
+              <a:schemeClr val="accent6">
+                <a:lumMod val="60000"/>
+                <a:lumOff val="40000"/>
+              </a:schemeClr>
+            </a:solidFill>
+            <a:prstDash val="sysDash"/>
+            <a:headEnd type="oval"/>
+            <a:tailEnd type="oval"/>
+          </a:ln>
+        </p:spPr>
+        <p:style>
+          <a:lnRef idx="1">
+            <a:schemeClr val="accent1"/>
+          </a:lnRef>
+          <a:fillRef idx="0">
+            <a:schemeClr val="accent1"/>
+          </a:fillRef>
+          <a:effectRef idx="0">
+            <a:schemeClr val="accent1"/>
+          </a:effectRef>
+          <a:fontRef idx="minor">
+            <a:schemeClr val="tx1"/>
+          </a:fontRef>
+        </p:style>
+      </p:cxnSp>
+      <p:cxnSp>
+        <p:nvCxnSpPr>
+          <p:cNvPr id="58" name="Straight Connector 57">
+            <a:extLst>
+              <a:ext uri="{FF2B5EF4-FFF2-40B4-BE49-F238E27FC236}">
+                <a16:creationId xmlns:a16="http://schemas.microsoft.com/office/drawing/2014/main" id="{7BDF191F-4792-4787-BA2F-DD56D22E007A}"/>
+              </a:ext>
+            </a:extLst>
+          </p:cNvPr>
+          <p:cNvCxnSpPr>
+            <a:cxnSpLocks/>
+          </p:cNvCxnSpPr>
+          <p:nvPr/>
+        </p:nvCxnSpPr>
+        <p:spPr>
+          <a:xfrm flipH="1" flipV="1">
+            <a:off x="7355297" y="4415605"/>
+            <a:ext cx="1829569" cy="186816"/>
+          </a:xfrm>
+          <a:prstGeom prst="line">
+            <a:avLst/>
+          </a:prstGeom>
+          <a:ln w="44450">
+            <a:solidFill>
+              <a:schemeClr val="accent6">
+                <a:lumMod val="60000"/>
+                <a:lumOff val="40000"/>
+              </a:schemeClr>
+            </a:solidFill>
+            <a:prstDash val="sysDash"/>
+            <a:headEnd type="oval"/>
+            <a:tailEnd type="oval"/>
+          </a:ln>
+        </p:spPr>
+        <p:style>
+          <a:lnRef idx="1">
+            <a:schemeClr val="accent1"/>
+          </a:lnRef>
+          <a:fillRef idx="0">
+            <a:schemeClr val="accent1"/>
+          </a:fillRef>
+          <a:effectRef idx="0">
+            <a:schemeClr val="accent1"/>
+          </a:effectRef>
+          <a:fontRef idx="minor">
+            <a:schemeClr val="tx1"/>
+          </a:fontRef>
+        </p:style>
+      </p:cxnSp>
+      <p:cxnSp>
+        <p:nvCxnSpPr>
+          <p:cNvPr id="63" name="Straight Arrow Connector 62">
+            <a:extLst>
+              <a:ext uri="{FF2B5EF4-FFF2-40B4-BE49-F238E27FC236}">
+                <a16:creationId xmlns:a16="http://schemas.microsoft.com/office/drawing/2014/main" id="{84193610-AA01-48D5-8BF7-0A30D3C6EAA1}"/>
+              </a:ext>
+            </a:extLst>
+          </p:cNvPr>
+          <p:cNvCxnSpPr>
+            <a:cxnSpLocks/>
+          </p:cNvCxnSpPr>
+          <p:nvPr/>
+        </p:nvCxnSpPr>
+        <p:spPr>
+          <a:xfrm>
+            <a:off x="2910348" y="2343080"/>
+            <a:ext cx="4376124" cy="2562059"/>
+          </a:xfrm>
+          <a:prstGeom prst="straightConnector1">
+            <a:avLst/>
+          </a:prstGeom>
+          <a:ln w="127000">
+            <a:solidFill>
+              <a:srgbClr val="FF0000"/>
+            </a:solidFill>
+            <a:tailEnd type="triangle"/>
+          </a:ln>
+        </p:spPr>
+        <p:style>
+          <a:lnRef idx="1">
+            <a:schemeClr val="accent1"/>
+          </a:lnRef>
+          <a:fillRef idx="0">
+            <a:schemeClr val="accent1"/>
+          </a:fillRef>
+          <a:effectRef idx="0">
+            <a:schemeClr val="accent1"/>
+          </a:effectRef>
+          <a:fontRef idx="minor">
+            <a:schemeClr val="tx1"/>
+          </a:fontRef>
+        </p:style>
+      </p:cxnSp>
+      <p:cxnSp>
+        <p:nvCxnSpPr>
+          <p:cNvPr id="65" name="Straight Arrow Connector 64">
+            <a:extLst>
+              <a:ext uri="{FF2B5EF4-FFF2-40B4-BE49-F238E27FC236}">
+                <a16:creationId xmlns:a16="http://schemas.microsoft.com/office/drawing/2014/main" id="{917FA0B0-9F58-4693-8BEB-157A520DE404}"/>
+              </a:ext>
+            </a:extLst>
+          </p:cNvPr>
+          <p:cNvCxnSpPr>
+            <a:cxnSpLocks/>
+          </p:cNvCxnSpPr>
+          <p:nvPr/>
+        </p:nvCxnSpPr>
+        <p:spPr>
+          <a:xfrm>
+            <a:off x="2546555" y="5536487"/>
+            <a:ext cx="6912077" cy="0"/>
+          </a:xfrm>
+          <a:prstGeom prst="straightConnector1">
+            <a:avLst/>
+          </a:prstGeom>
+          <a:ln>
+            <a:tailEnd type="triangle"/>
+          </a:ln>
+        </p:spPr>
+        <p:style>
+          <a:lnRef idx="1">
+            <a:schemeClr val="accent1"/>
+          </a:lnRef>
+          <a:fillRef idx="0">
+            <a:schemeClr val="accent1"/>
+          </a:fillRef>
+          <a:effectRef idx="0">
+            <a:schemeClr val="accent1"/>
+          </a:effectRef>
+          <a:fontRef idx="minor">
+            <a:schemeClr val="tx1"/>
+          </a:fontRef>
+        </p:style>
+      </p:cxnSp>
+      <p:sp>
+        <p:nvSpPr>
+          <p:cNvPr id="66" name="TextBox 65">
+            <a:extLst>
+              <a:ext uri="{FF2B5EF4-FFF2-40B4-BE49-F238E27FC236}">
+                <a16:creationId xmlns:a16="http://schemas.microsoft.com/office/drawing/2014/main" id="{03708F32-A585-428A-84C4-716D41FFAD7F}"/>
+              </a:ext>
+            </a:extLst>
+          </p:cNvPr>
+          <p:cNvSpPr txBox="1"/>
+          <p:nvPr/>
+        </p:nvSpPr>
+        <p:spPr>
+          <a:xfrm>
+            <a:off x="2546556" y="5536487"/>
+            <a:ext cx="6912076" cy="830997"/>
+          </a:xfrm>
+          <a:prstGeom prst="rect">
+            <a:avLst/>
+          </a:prstGeom>
+          <a:noFill/>
+        </p:spPr>
+        <p:txBody>
+          <a:bodyPr wrap="square" rtlCol="0">
+            <a:spAutoFit/>
+          </a:bodyPr>
+          <a:lstStyle/>
+          <a:p>
+            <a:pPr algn="ctr"/>
+            <a:r>
+              <a:rPr lang="en-US" sz="4800" b="1" dirty="0"/>
+              <a:t>Time</a:t>
+            </a:r>
+          </a:p>
+        </p:txBody>
+      </p:sp>
+      <p:cxnSp>
+        <p:nvCxnSpPr>
+          <p:cNvPr id="69" name="Straight Arrow Connector 68">
+            <a:extLst>
+              <a:ext uri="{FF2B5EF4-FFF2-40B4-BE49-F238E27FC236}">
+                <a16:creationId xmlns:a16="http://schemas.microsoft.com/office/drawing/2014/main" id="{414BB64C-7876-484A-BA14-DD8193E775CC}"/>
+              </a:ext>
+            </a:extLst>
+          </p:cNvPr>
+          <p:cNvCxnSpPr>
+            <a:cxnSpLocks/>
+          </p:cNvCxnSpPr>
+          <p:nvPr/>
+        </p:nvCxnSpPr>
+        <p:spPr>
+          <a:xfrm flipV="1">
+            <a:off x="2551470" y="1071715"/>
+            <a:ext cx="0" cy="4459855"/>
+          </a:xfrm>
+          <a:prstGeom prst="straightConnector1">
+            <a:avLst/>
+          </a:prstGeom>
+          <a:ln>
+            <a:tailEnd type="triangle"/>
+          </a:ln>
+        </p:spPr>
+        <p:style>
+          <a:lnRef idx="1">
+            <a:schemeClr val="accent1"/>
+          </a:lnRef>
+          <a:fillRef idx="0">
+            <a:schemeClr val="accent1"/>
+          </a:fillRef>
+          <a:effectRef idx="0">
+            <a:schemeClr val="accent1"/>
+          </a:effectRef>
+          <a:fontRef idx="minor">
+            <a:schemeClr val="tx1"/>
+          </a:fontRef>
+        </p:style>
+      </p:cxnSp>
+      <p:sp>
+        <p:nvSpPr>
+          <p:cNvPr id="71" name="TextBox 70">
+            <a:extLst>
+              <a:ext uri="{FF2B5EF4-FFF2-40B4-BE49-F238E27FC236}">
+                <a16:creationId xmlns:a16="http://schemas.microsoft.com/office/drawing/2014/main" id="{47686B11-96EA-4337-8C16-E4643F8A6AC8}"/>
+              </a:ext>
+            </a:extLst>
+          </p:cNvPr>
+          <p:cNvSpPr txBox="1"/>
+          <p:nvPr/>
+        </p:nvSpPr>
+        <p:spPr>
+          <a:xfrm rot="16200000">
+            <a:off x="-101242" y="2886144"/>
+            <a:ext cx="4459854" cy="830997"/>
+          </a:xfrm>
+          <a:prstGeom prst="rect">
+            <a:avLst/>
+          </a:prstGeom>
+          <a:noFill/>
+        </p:spPr>
+        <p:txBody>
+          <a:bodyPr wrap="square" rtlCol="0">
+            <a:spAutoFit/>
+          </a:bodyPr>
+          <a:lstStyle/>
+          <a:p>
+            <a:pPr algn="ctr"/>
+            <a:r>
+              <a:rPr lang="en-US" sz="4800" b="1" dirty="0"/>
+              <a:t>Size</a:t>
+            </a:r>
+          </a:p>
+        </p:txBody>
+      </p:sp>
+    </p:spTree>
+    <p:extLst>
+      <p:ext uri="{BB962C8B-B14F-4D97-AF65-F5344CB8AC3E}">
+        <p14:creationId xmlns:p14="http://schemas.microsoft.com/office/powerpoint/2010/main" val="978205189"/>
+      </p:ext>
+    </p:extLst>
+  </p:cSld>
+  <p:clrMapOvr>
+    <a:masterClrMapping/>
+  </p:clrMapOvr>
+</p:sld>
+</file>
+
+<file path=ppt/slides/slide6.xml><?xml version="1.0" encoding="utf-8"?>
+<p:sld xmlns:a="http://schemas.openxmlformats.org/drawingml/2006/main" xmlns:r="http://schemas.openxmlformats.org/officeDocument/2006/relationships" xmlns:p="http://schemas.openxmlformats.org/presentationml/2006/main">
+  <p:cSld>
+    <p:spTree>
+      <p:nvGrpSpPr>
+        <p:cNvPr id="1" name=""/>
+        <p:cNvGrpSpPr/>
+        <p:nvPr/>
+      </p:nvGrpSpPr>
+      <p:grpSpPr>
+        <a:xfrm>
+          <a:off x="0" y="0"/>
+          <a:ext cx="0" cy="0"/>
+          <a:chOff x="0" y="0"/>
+          <a:chExt cx="0" cy="0"/>
+        </a:xfrm>
+      </p:grpSpPr>
+      <p:pic>
+        <p:nvPicPr>
+          <p:cNvPr id="5" name="Picture 4">
+            <a:extLst>
+              <a:ext uri="{FF2B5EF4-FFF2-40B4-BE49-F238E27FC236}">
+                <a16:creationId xmlns:a16="http://schemas.microsoft.com/office/drawing/2014/main" id="{02FAE5D3-72ED-4514-910A-1B5473FBC81F}"/>
+              </a:ext>
+            </a:extLst>
+          </p:cNvPr>
+          <p:cNvPicPr>
+            <a:picLocks noChangeAspect="1"/>
+          </p:cNvPicPr>
+          <p:nvPr/>
+        </p:nvPicPr>
+        <p:blipFill rotWithShape="1">
+          <a:blip r:embed="rId2">
+            <a:extLst>
+              <a:ext uri="{28A0092B-C50C-407E-A947-70E740481C1C}">
+                <a14:useLocalDpi xmlns:a14="http://schemas.microsoft.com/office/drawing/2010/main" val="0"/>
+              </a:ext>
+            </a:extLst>
+          </a:blip>
+          <a:srcRect t="12217"/>
+          <a:stretch/>
+        </p:blipFill>
+        <p:spPr>
+          <a:xfrm>
+            <a:off x="1846796" y="1759973"/>
+            <a:ext cx="8605490" cy="3814917"/>
+          </a:xfrm>
+          <a:prstGeom prst="rect">
+            <a:avLst/>
+          </a:prstGeom>
+        </p:spPr>
+      </p:pic>
+    </p:spTree>
+    <p:extLst>
+      <p:ext uri="{BB962C8B-B14F-4D97-AF65-F5344CB8AC3E}">
+        <p14:creationId xmlns:p14="http://schemas.microsoft.com/office/powerpoint/2010/main" val="2662466891"/>
+      </p:ext>
+    </p:extLst>
+  </p:cSld>
+  <p:clrMapOvr>
+    <a:masterClrMapping/>
+  </p:clrMapOvr>
+</p:sld>
+</file>
+
 <file path=ppt/theme/theme1.xml><?xml version="1.0" encoding="utf-8"?>
 <a:theme xmlns:a="http://schemas.openxmlformats.org/drawingml/2006/main" name="Office Theme">
   <a:themeElements>

</xml_diff>

<commit_message>
add productivity module and fix some module interactions
</commit_message>
<xml_diff>
--- a/SALT_icons.pptx
+++ b/SALT_icons.pptx
@@ -11,6 +11,7 @@
     <p:sldId id="259" r:id="rId5"/>
     <p:sldId id="260" r:id="rId6"/>
     <p:sldId id="261" r:id="rId7"/>
+    <p:sldId id="262" r:id="rId8"/>
   </p:sldIdLst>
   <p:sldSz cx="12192000" cy="6858000"/>
   <p:notesSz cx="6858000" cy="9144000"/>
@@ -7233,6 +7234,387 @@
 </p:sld>
 </file>
 
+<file path=ppt/slides/slide7.xml><?xml version="1.0" encoding="utf-8"?>
+<p:sld xmlns:a="http://schemas.openxmlformats.org/drawingml/2006/main" xmlns:r="http://schemas.openxmlformats.org/officeDocument/2006/relationships" xmlns:p="http://schemas.openxmlformats.org/presentationml/2006/main">
+  <p:cSld>
+    <p:spTree>
+      <p:nvGrpSpPr>
+        <p:cNvPr id="1" name=""/>
+        <p:cNvGrpSpPr/>
+        <p:nvPr/>
+      </p:nvGrpSpPr>
+      <p:grpSpPr>
+        <a:xfrm>
+          <a:off x="0" y="0"/>
+          <a:ext cx="0" cy="0"/>
+          <a:chOff x="0" y="0"/>
+          <a:chExt cx="0" cy="0"/>
+        </a:xfrm>
+      </p:grpSpPr>
+      <p:pic>
+        <p:nvPicPr>
+          <p:cNvPr id="1026" name="Picture 2" descr="Plot object">
+            <a:extLst>
+              <a:ext uri="{FF2B5EF4-FFF2-40B4-BE49-F238E27FC236}">
+                <a16:creationId xmlns:a16="http://schemas.microsoft.com/office/drawing/2014/main" id="{BA82108A-F4F7-4AE3-9A79-E8B61A75A88A}"/>
+              </a:ext>
+            </a:extLst>
+          </p:cNvPr>
+          <p:cNvPicPr>
+            <a:picLocks noChangeAspect="1" noChangeArrowheads="1"/>
+          </p:cNvPicPr>
+          <p:nvPr/>
+        </p:nvPicPr>
+        <p:blipFill rotWithShape="1">
+          <a:blip r:embed="rId2">
+            <a:extLst>
+              <a:ext uri="{28A0092B-C50C-407E-A947-70E740481C1C}">
+                <a14:useLocalDpi xmlns:a14="http://schemas.microsoft.com/office/drawing/2010/main" val="0"/>
+              </a:ext>
+            </a:extLst>
+          </a:blip>
+          <a:srcRect t="10656"/>
+          <a:stretch/>
+        </p:blipFill>
+        <p:spPr bwMode="auto">
+          <a:xfrm>
+            <a:off x="1006427" y="707923"/>
+            <a:ext cx="9924923" cy="5181601"/>
+          </a:xfrm>
+          <a:prstGeom prst="rect">
+            <a:avLst/>
+          </a:prstGeom>
+          <a:noFill/>
+          <a:extLst>
+            <a:ext uri="{909E8E84-426E-40DD-AFC4-6F175D3DCCD1}">
+              <a14:hiddenFill xmlns:a14="http://schemas.microsoft.com/office/drawing/2010/main">
+                <a:solidFill>
+                  <a:srgbClr val="FFFFFF"/>
+                </a:solidFill>
+              </a14:hiddenFill>
+            </a:ext>
+          </a:extLst>
+        </p:spPr>
+      </p:pic>
+      <p:sp>
+        <p:nvSpPr>
+          <p:cNvPr id="6" name="Freeform: Shape 5">
+            <a:extLst>
+              <a:ext uri="{FF2B5EF4-FFF2-40B4-BE49-F238E27FC236}">
+                <a16:creationId xmlns:a16="http://schemas.microsoft.com/office/drawing/2014/main" id="{A94439D9-F5C9-469B-9F54-CEBA3FEBFC1F}"/>
+              </a:ext>
+            </a:extLst>
+          </p:cNvPr>
+          <p:cNvSpPr/>
+          <p:nvPr/>
+        </p:nvSpPr>
+        <p:spPr>
+          <a:xfrm>
+            <a:off x="2064774" y="883161"/>
+            <a:ext cx="8327923" cy="4082129"/>
+          </a:xfrm>
+          <a:custGeom>
+            <a:avLst/>
+            <a:gdLst>
+              <a:gd name="connsiteX0" fmla="*/ 0 w 8327923"/>
+              <a:gd name="connsiteY0" fmla="*/ 3688839 h 4082129"/>
+              <a:gd name="connsiteX1" fmla="*/ 560439 w 8327923"/>
+              <a:gd name="connsiteY1" fmla="*/ 1860039 h 4082129"/>
+              <a:gd name="connsiteX2" fmla="*/ 1396181 w 8327923"/>
+              <a:gd name="connsiteY2" fmla="*/ 542516 h 4082129"/>
+              <a:gd name="connsiteX3" fmla="*/ 2290916 w 8327923"/>
+              <a:gd name="connsiteY3" fmla="*/ 50904 h 4082129"/>
+              <a:gd name="connsiteX4" fmla="*/ 3048000 w 8327923"/>
+              <a:gd name="connsiteY4" fmla="*/ 41071 h 4082129"/>
+              <a:gd name="connsiteX5" fmla="*/ 3844413 w 8327923"/>
+              <a:gd name="connsiteY5" fmla="*/ 277045 h 4082129"/>
+              <a:gd name="connsiteX6" fmla="*/ 5319252 w 8327923"/>
+              <a:gd name="connsiteY6" fmla="*/ 1181613 h 4082129"/>
+              <a:gd name="connsiteX7" fmla="*/ 6803923 w 8327923"/>
+              <a:gd name="connsiteY7" fmla="*/ 2420478 h 4082129"/>
+              <a:gd name="connsiteX8" fmla="*/ 8327923 w 8327923"/>
+              <a:gd name="connsiteY8" fmla="*/ 4082129 h 4082129"/>
+            </a:gdLst>
+            <a:ahLst/>
+            <a:cxnLst>
+              <a:cxn ang="0">
+                <a:pos x="connsiteX0" y="connsiteY0"/>
+              </a:cxn>
+              <a:cxn ang="0">
+                <a:pos x="connsiteX1" y="connsiteY1"/>
+              </a:cxn>
+              <a:cxn ang="0">
+                <a:pos x="connsiteX2" y="connsiteY2"/>
+              </a:cxn>
+              <a:cxn ang="0">
+                <a:pos x="connsiteX3" y="connsiteY3"/>
+              </a:cxn>
+              <a:cxn ang="0">
+                <a:pos x="connsiteX4" y="connsiteY4"/>
+              </a:cxn>
+              <a:cxn ang="0">
+                <a:pos x="connsiteX5" y="connsiteY5"/>
+              </a:cxn>
+              <a:cxn ang="0">
+                <a:pos x="connsiteX6" y="connsiteY6"/>
+              </a:cxn>
+              <a:cxn ang="0">
+                <a:pos x="connsiteX7" y="connsiteY7"/>
+              </a:cxn>
+              <a:cxn ang="0">
+                <a:pos x="connsiteX8" y="connsiteY8"/>
+              </a:cxn>
+            </a:cxnLst>
+            <a:rect l="l" t="t" r="r" b="b"/>
+            <a:pathLst>
+              <a:path w="8327923" h="4082129">
+                <a:moveTo>
+                  <a:pt x="0" y="3688839"/>
+                </a:moveTo>
+                <a:cubicBezTo>
+                  <a:pt x="163871" y="3036632"/>
+                  <a:pt x="327742" y="2384426"/>
+                  <a:pt x="560439" y="1860039"/>
+                </a:cubicBezTo>
+                <a:cubicBezTo>
+                  <a:pt x="793136" y="1335652"/>
+                  <a:pt x="1107768" y="844038"/>
+                  <a:pt x="1396181" y="542516"/>
+                </a:cubicBezTo>
+                <a:cubicBezTo>
+                  <a:pt x="1684594" y="240993"/>
+                  <a:pt x="2015613" y="134478"/>
+                  <a:pt x="2290916" y="50904"/>
+                </a:cubicBezTo>
+                <a:cubicBezTo>
+                  <a:pt x="2566219" y="-32670"/>
+                  <a:pt x="2789084" y="3381"/>
+                  <a:pt x="3048000" y="41071"/>
+                </a:cubicBezTo>
+                <a:cubicBezTo>
+                  <a:pt x="3306916" y="78761"/>
+                  <a:pt x="3465871" y="86955"/>
+                  <a:pt x="3844413" y="277045"/>
+                </a:cubicBezTo>
+                <a:cubicBezTo>
+                  <a:pt x="4222955" y="467135"/>
+                  <a:pt x="4826000" y="824374"/>
+                  <a:pt x="5319252" y="1181613"/>
+                </a:cubicBezTo>
+                <a:cubicBezTo>
+                  <a:pt x="5812504" y="1538852"/>
+                  <a:pt x="6302478" y="1937059"/>
+                  <a:pt x="6803923" y="2420478"/>
+                </a:cubicBezTo>
+                <a:cubicBezTo>
+                  <a:pt x="7305368" y="2903897"/>
+                  <a:pt x="7816645" y="3493013"/>
+                  <a:pt x="8327923" y="4082129"/>
+                </a:cubicBezTo>
+              </a:path>
+            </a:pathLst>
+          </a:custGeom>
+          <a:noFill/>
+          <a:ln w="127000">
+            <a:solidFill>
+              <a:schemeClr val="tx1">
+                <a:lumMod val="95000"/>
+                <a:lumOff val="5000"/>
+              </a:schemeClr>
+            </a:solidFill>
+          </a:ln>
+        </p:spPr>
+        <p:style>
+          <a:lnRef idx="2">
+            <a:schemeClr val="accent1">
+              <a:shade val="50000"/>
+            </a:schemeClr>
+          </a:lnRef>
+          <a:fillRef idx="1">
+            <a:schemeClr val="accent1"/>
+          </a:fillRef>
+          <a:effectRef idx="0">
+            <a:schemeClr val="accent1"/>
+          </a:effectRef>
+          <a:fontRef idx="minor">
+            <a:schemeClr val="lt1"/>
+          </a:fontRef>
+        </p:style>
+        <p:txBody>
+          <a:bodyPr rtlCol="0" anchor="ctr"/>
+          <a:lstStyle/>
+          <a:p>
+            <a:pPr algn="ctr"/>
+            <a:endParaRPr lang="en-US"/>
+          </a:p>
+        </p:txBody>
+      </p:sp>
+      <p:sp>
+        <p:nvSpPr>
+          <p:cNvPr id="7" name="Oval 6">
+            <a:extLst>
+              <a:ext uri="{FF2B5EF4-FFF2-40B4-BE49-F238E27FC236}">
+                <a16:creationId xmlns:a16="http://schemas.microsoft.com/office/drawing/2014/main" id="{47202274-8581-4A4D-A5B0-2A22B2287C1F}"/>
+              </a:ext>
+            </a:extLst>
+          </p:cNvPr>
+          <p:cNvSpPr>
+            <a:spLocks noChangeAspect="1"/>
+          </p:cNvSpPr>
+          <p:nvPr/>
+        </p:nvSpPr>
+        <p:spPr>
+          <a:xfrm>
+            <a:off x="4552338" y="688261"/>
+            <a:ext cx="363037" cy="365760"/>
+          </a:xfrm>
+          <a:prstGeom prst="ellipse">
+            <a:avLst/>
+          </a:prstGeom>
+          <a:solidFill>
+            <a:srgbClr val="FF0000"/>
+          </a:solidFill>
+        </p:spPr>
+        <p:style>
+          <a:lnRef idx="2">
+            <a:schemeClr val="accent1">
+              <a:shade val="50000"/>
+            </a:schemeClr>
+          </a:lnRef>
+          <a:fillRef idx="1">
+            <a:schemeClr val="accent1"/>
+          </a:fillRef>
+          <a:effectRef idx="0">
+            <a:schemeClr val="accent1"/>
+          </a:effectRef>
+          <a:fontRef idx="minor">
+            <a:schemeClr val="lt1"/>
+          </a:fontRef>
+        </p:style>
+        <p:txBody>
+          <a:bodyPr rtlCol="0" anchor="ctr"/>
+          <a:lstStyle/>
+          <a:p>
+            <a:pPr algn="ctr"/>
+            <a:endParaRPr lang="en-US"/>
+          </a:p>
+        </p:txBody>
+      </p:sp>
+      <p:sp>
+        <p:nvSpPr>
+          <p:cNvPr id="9" name="Oval 8">
+            <a:extLst>
+              <a:ext uri="{FF2B5EF4-FFF2-40B4-BE49-F238E27FC236}">
+                <a16:creationId xmlns:a16="http://schemas.microsoft.com/office/drawing/2014/main" id="{1C048C52-728F-40CB-B616-F65A98AB5A09}"/>
+              </a:ext>
+            </a:extLst>
+          </p:cNvPr>
+          <p:cNvSpPr>
+            <a:spLocks noChangeAspect="1"/>
+          </p:cNvSpPr>
+          <p:nvPr/>
+        </p:nvSpPr>
+        <p:spPr>
+          <a:xfrm>
+            <a:off x="2993921" y="1538752"/>
+            <a:ext cx="363037" cy="365760"/>
+          </a:xfrm>
+          <a:prstGeom prst="ellipse">
+            <a:avLst/>
+          </a:prstGeom>
+          <a:solidFill>
+            <a:srgbClr val="7030A0"/>
+          </a:solidFill>
+        </p:spPr>
+        <p:style>
+          <a:lnRef idx="2">
+            <a:schemeClr val="accent1">
+              <a:shade val="50000"/>
+            </a:schemeClr>
+          </a:lnRef>
+          <a:fillRef idx="1">
+            <a:schemeClr val="accent1"/>
+          </a:fillRef>
+          <a:effectRef idx="0">
+            <a:schemeClr val="accent1"/>
+          </a:effectRef>
+          <a:fontRef idx="minor">
+            <a:schemeClr val="lt1"/>
+          </a:fontRef>
+        </p:style>
+        <p:txBody>
+          <a:bodyPr rtlCol="0" anchor="ctr"/>
+          <a:lstStyle/>
+          <a:p>
+            <a:pPr algn="ctr"/>
+            <a:endParaRPr lang="en-US"/>
+          </a:p>
+        </p:txBody>
+      </p:sp>
+      <p:sp>
+        <p:nvSpPr>
+          <p:cNvPr id="10" name="Oval 9">
+            <a:extLst>
+              <a:ext uri="{FF2B5EF4-FFF2-40B4-BE49-F238E27FC236}">
+                <a16:creationId xmlns:a16="http://schemas.microsoft.com/office/drawing/2014/main" id="{A77C32EE-00A7-4D26-A48C-1758EE241BE1}"/>
+              </a:ext>
+            </a:extLst>
+          </p:cNvPr>
+          <p:cNvSpPr>
+            <a:spLocks noChangeAspect="1"/>
+          </p:cNvSpPr>
+          <p:nvPr/>
+        </p:nvSpPr>
+        <p:spPr>
+          <a:xfrm>
+            <a:off x="6725271" y="1543664"/>
+            <a:ext cx="363037" cy="365760"/>
+          </a:xfrm>
+          <a:prstGeom prst="ellipse">
+            <a:avLst/>
+          </a:prstGeom>
+          <a:solidFill>
+            <a:srgbClr val="7030A0"/>
+          </a:solidFill>
+        </p:spPr>
+        <p:style>
+          <a:lnRef idx="2">
+            <a:schemeClr val="accent1">
+              <a:shade val="50000"/>
+            </a:schemeClr>
+          </a:lnRef>
+          <a:fillRef idx="1">
+            <a:schemeClr val="accent1"/>
+          </a:fillRef>
+          <a:effectRef idx="0">
+            <a:schemeClr val="accent1"/>
+          </a:effectRef>
+          <a:fontRef idx="minor">
+            <a:schemeClr val="lt1"/>
+          </a:fontRef>
+        </p:style>
+        <p:txBody>
+          <a:bodyPr rtlCol="0" anchor="ctr"/>
+          <a:lstStyle/>
+          <a:p>
+            <a:pPr algn="ctr"/>
+            <a:endParaRPr lang="en-US"/>
+          </a:p>
+        </p:txBody>
+      </p:sp>
+    </p:spTree>
+    <p:extLst>
+      <p:ext uri="{BB962C8B-B14F-4D97-AF65-F5344CB8AC3E}">
+        <p14:creationId xmlns:p14="http://schemas.microsoft.com/office/powerpoint/2010/main" val="3327130451"/>
+      </p:ext>
+    </p:extLst>
+  </p:cSld>
+  <p:clrMapOvr>
+    <a:masterClrMapping/>
+  </p:clrMapOvr>
+</p:sld>
+</file>
+
 <file path=ppt/theme/theme1.xml><?xml version="1.0" encoding="utf-8"?>
 <a:theme xmlns:a="http://schemas.openxmlformats.org/drawingml/2006/main" name="Office Theme">
   <a:themeElements>

</xml_diff>

<commit_message>
add Indicator module to main tool
</commit_message>
<xml_diff>
--- a/SALT_icons.pptx
+++ b/SALT_icons.pptx
@@ -5,7 +5,7 @@
     <p:sldMasterId id="2147483648" r:id="rId1"/>
   </p:sldMasterIdLst>
   <p:notesMasterIdLst>
-    <p:notesMasterId r:id="rId10"/>
+    <p:notesMasterId r:id="rId12"/>
   </p:notesMasterIdLst>
   <p:sldIdLst>
     <p:sldId id="256" r:id="rId2"/>
@@ -16,6 +16,8 @@
     <p:sldId id="261" r:id="rId7"/>
     <p:sldId id="262" r:id="rId8"/>
     <p:sldId id="263" r:id="rId9"/>
+    <p:sldId id="264" r:id="rId10"/>
+    <p:sldId id="265" r:id="rId11"/>
   </p:sldIdLst>
   <p:sldSz cx="12192000" cy="6858000"/>
   <p:notesSz cx="6858000" cy="9144000"/>
@@ -204,7 +206,7 @@
           <a:p>
             <a:fld id="{25BA9636-C812-4FA3-A200-DB6EEA015C62}" type="datetimeFigureOut">
               <a:rPr lang="en-US" smtClean="0"/>
-              <a:t>12/11/2025</a:t>
+              <a:t>12/15/2025</a:t>
             </a:fld>
             <a:endParaRPr lang="en-US"/>
           </a:p>
@@ -702,7 +704,7 @@
           <a:p>
             <a:fld id="{A52A0AC6-1FC2-46EF-B96C-23ED3DABE568}" type="datetimeFigureOut">
               <a:rPr lang="en-US" smtClean="0"/>
-              <a:t>12/9/2025</a:t>
+              <a:t>12/15/2025</a:t>
             </a:fld>
             <a:endParaRPr lang="en-US"/>
           </a:p>
@@ -900,7 +902,7 @@
           <a:p>
             <a:fld id="{A52A0AC6-1FC2-46EF-B96C-23ED3DABE568}" type="datetimeFigureOut">
               <a:rPr lang="en-US" smtClean="0"/>
-              <a:t>12/9/2025</a:t>
+              <a:t>12/15/2025</a:t>
             </a:fld>
             <a:endParaRPr lang="en-US"/>
           </a:p>
@@ -1108,7 +1110,7 @@
           <a:p>
             <a:fld id="{A52A0AC6-1FC2-46EF-B96C-23ED3DABE568}" type="datetimeFigureOut">
               <a:rPr lang="en-US" smtClean="0"/>
-              <a:t>12/9/2025</a:t>
+              <a:t>12/15/2025</a:t>
             </a:fld>
             <a:endParaRPr lang="en-US"/>
           </a:p>
@@ -1306,7 +1308,7 @@
           <a:p>
             <a:fld id="{A52A0AC6-1FC2-46EF-B96C-23ED3DABE568}" type="datetimeFigureOut">
               <a:rPr lang="en-US" smtClean="0"/>
-              <a:t>12/9/2025</a:t>
+              <a:t>12/15/2025</a:t>
             </a:fld>
             <a:endParaRPr lang="en-US"/>
           </a:p>
@@ -1581,7 +1583,7 @@
           <a:p>
             <a:fld id="{A52A0AC6-1FC2-46EF-B96C-23ED3DABE568}" type="datetimeFigureOut">
               <a:rPr lang="en-US" smtClean="0"/>
-              <a:t>12/9/2025</a:t>
+              <a:t>12/15/2025</a:t>
             </a:fld>
             <a:endParaRPr lang="en-US"/>
           </a:p>
@@ -1846,7 +1848,7 @@
           <a:p>
             <a:fld id="{A52A0AC6-1FC2-46EF-B96C-23ED3DABE568}" type="datetimeFigureOut">
               <a:rPr lang="en-US" smtClean="0"/>
-              <a:t>12/9/2025</a:t>
+              <a:t>12/15/2025</a:t>
             </a:fld>
             <a:endParaRPr lang="en-US"/>
           </a:p>
@@ -2258,7 +2260,7 @@
           <a:p>
             <a:fld id="{A52A0AC6-1FC2-46EF-B96C-23ED3DABE568}" type="datetimeFigureOut">
               <a:rPr lang="en-US" smtClean="0"/>
-              <a:t>12/9/2025</a:t>
+              <a:t>12/15/2025</a:t>
             </a:fld>
             <a:endParaRPr lang="en-US"/>
           </a:p>
@@ -2399,7 +2401,7 @@
           <a:p>
             <a:fld id="{A52A0AC6-1FC2-46EF-B96C-23ED3DABE568}" type="datetimeFigureOut">
               <a:rPr lang="en-US" smtClean="0"/>
-              <a:t>12/9/2025</a:t>
+              <a:t>12/15/2025</a:t>
             </a:fld>
             <a:endParaRPr lang="en-US"/>
           </a:p>
@@ -2512,7 +2514,7 @@
           <a:p>
             <a:fld id="{A52A0AC6-1FC2-46EF-B96C-23ED3DABE568}" type="datetimeFigureOut">
               <a:rPr lang="en-US" smtClean="0"/>
-              <a:t>12/9/2025</a:t>
+              <a:t>12/15/2025</a:t>
             </a:fld>
             <a:endParaRPr lang="en-US"/>
           </a:p>
@@ -2823,7 +2825,7 @@
           <a:p>
             <a:fld id="{A52A0AC6-1FC2-46EF-B96C-23ED3DABE568}" type="datetimeFigureOut">
               <a:rPr lang="en-US" smtClean="0"/>
-              <a:t>12/9/2025</a:t>
+              <a:t>12/15/2025</a:t>
             </a:fld>
             <a:endParaRPr lang="en-US"/>
           </a:p>
@@ -3111,7 +3113,7 @@
           <a:p>
             <a:fld id="{A52A0AC6-1FC2-46EF-B96C-23ED3DABE568}" type="datetimeFigureOut">
               <a:rPr lang="en-US" smtClean="0"/>
-              <a:t>12/9/2025</a:t>
+              <a:t>12/15/2025</a:t>
             </a:fld>
             <a:endParaRPr lang="en-US"/>
           </a:p>
@@ -3352,7 +3354,7 @@
           <a:p>
             <a:fld id="{A52A0AC6-1FC2-46EF-B96C-23ED3DABE568}" type="datetimeFigureOut">
               <a:rPr lang="en-US" smtClean="0"/>
-              <a:t>12/9/2025</a:t>
+              <a:t>12/15/2025</a:t>
             </a:fld>
             <a:endParaRPr lang="en-US"/>
           </a:p>
@@ -4299,6 +4301,65 @@
 </p:sld>
 </file>
 
+<file path=ppt/slides/slide10.xml><?xml version="1.0" encoding="utf-8"?>
+<p:sld xmlns:a="http://schemas.openxmlformats.org/drawingml/2006/main" xmlns:r="http://schemas.openxmlformats.org/officeDocument/2006/relationships" xmlns:p="http://schemas.openxmlformats.org/presentationml/2006/main">
+  <p:cSld>
+    <p:spTree>
+      <p:nvGrpSpPr>
+        <p:cNvPr id="1" name=""/>
+        <p:cNvGrpSpPr/>
+        <p:nvPr/>
+      </p:nvGrpSpPr>
+      <p:grpSpPr>
+        <a:xfrm>
+          <a:off x="0" y="0"/>
+          <a:ext cx="0" cy="0"/>
+          <a:chOff x="0" y="0"/>
+          <a:chExt cx="0" cy="0"/>
+        </a:xfrm>
+      </p:grpSpPr>
+      <p:pic>
+        <p:nvPicPr>
+          <p:cNvPr id="4" name="Picture 3">
+            <a:extLst>
+              <a:ext uri="{FF2B5EF4-FFF2-40B4-BE49-F238E27FC236}">
+                <a16:creationId xmlns:a16="http://schemas.microsoft.com/office/drawing/2014/main" id="{3BE183E7-E11D-43DE-9C38-68698D46AB96}"/>
+              </a:ext>
+            </a:extLst>
+          </p:cNvPr>
+          <p:cNvPicPr>
+            <a:picLocks noChangeAspect="1"/>
+          </p:cNvPicPr>
+          <p:nvPr/>
+        </p:nvPicPr>
+        <p:blipFill rotWithShape="1">
+          <a:blip r:embed="rId2"/>
+          <a:srcRect t="12071" b="12573"/>
+          <a:stretch/>
+        </p:blipFill>
+        <p:spPr>
+          <a:xfrm>
+            <a:off x="1040115" y="951026"/>
+            <a:ext cx="9551685" cy="5325950"/>
+          </a:xfrm>
+          <a:prstGeom prst="rect">
+            <a:avLst/>
+          </a:prstGeom>
+        </p:spPr>
+      </p:pic>
+    </p:spTree>
+    <p:extLst>
+      <p:ext uri="{BB962C8B-B14F-4D97-AF65-F5344CB8AC3E}">
+        <p14:creationId xmlns:p14="http://schemas.microsoft.com/office/powerpoint/2010/main" val="4120203952"/>
+      </p:ext>
+    </p:extLst>
+  </p:cSld>
+  <p:clrMapOvr>
+    <a:masterClrMapping/>
+  </p:clrMapOvr>
+</p:sld>
+</file>
+
 <file path=ppt/slides/slide2.xml><?xml version="1.0" encoding="utf-8"?>
 <p:sld xmlns:a="http://schemas.openxmlformats.org/drawingml/2006/main" xmlns:r="http://schemas.openxmlformats.org/officeDocument/2006/relationships" xmlns:p="http://schemas.openxmlformats.org/presentationml/2006/main">
   <p:cSld>
@@ -8168,6 +8229,173 @@
     <p:extLst>
       <p:ext uri="{BB962C8B-B14F-4D97-AF65-F5344CB8AC3E}">
         <p14:creationId xmlns:p14="http://schemas.microsoft.com/office/powerpoint/2010/main" val="4123145027"/>
+      </p:ext>
+    </p:extLst>
+  </p:cSld>
+  <p:clrMapOvr>
+    <a:masterClrMapping/>
+  </p:clrMapOvr>
+</p:sld>
+</file>
+
+<file path=ppt/slides/slide9.xml><?xml version="1.0" encoding="utf-8"?>
+<p:sld xmlns:a="http://schemas.openxmlformats.org/drawingml/2006/main" xmlns:r="http://schemas.openxmlformats.org/officeDocument/2006/relationships" xmlns:p="http://schemas.openxmlformats.org/presentationml/2006/main">
+  <p:cSld>
+    <p:spTree>
+      <p:nvGrpSpPr>
+        <p:cNvPr id="1" name=""/>
+        <p:cNvGrpSpPr/>
+        <p:nvPr/>
+      </p:nvGrpSpPr>
+      <p:grpSpPr>
+        <a:xfrm>
+          <a:off x="0" y="0"/>
+          <a:ext cx="0" cy="0"/>
+          <a:chOff x="0" y="0"/>
+          <a:chExt cx="0" cy="0"/>
+        </a:xfrm>
+      </p:grpSpPr>
+      <p:pic>
+        <p:nvPicPr>
+          <p:cNvPr id="4" name="Picture 3">
+            <a:extLst>
+              <a:ext uri="{FF2B5EF4-FFF2-40B4-BE49-F238E27FC236}">
+                <a16:creationId xmlns:a16="http://schemas.microsoft.com/office/drawing/2014/main" id="{22D4FFEA-5A42-4D86-9D8E-E3805A0B6495}"/>
+              </a:ext>
+            </a:extLst>
+          </p:cNvPr>
+          <p:cNvPicPr>
+            <a:picLocks noChangeAspect="1"/>
+          </p:cNvPicPr>
+          <p:nvPr/>
+        </p:nvPicPr>
+        <p:blipFill rotWithShape="1">
+          <a:blip r:embed="rId2"/>
+          <a:srcRect l="36976" r="32599" b="8816"/>
+          <a:stretch/>
+        </p:blipFill>
+        <p:spPr>
+          <a:xfrm>
+            <a:off x="4438650" y="1115521"/>
+            <a:ext cx="3533775" cy="4626957"/>
+          </a:xfrm>
+          <a:prstGeom prst="rect">
+            <a:avLst/>
+          </a:prstGeom>
+        </p:spPr>
+      </p:pic>
+      <p:sp>
+        <p:nvSpPr>
+          <p:cNvPr id="7" name="Rectangle 6">
+            <a:extLst>
+              <a:ext uri="{FF2B5EF4-FFF2-40B4-BE49-F238E27FC236}">
+                <a16:creationId xmlns:a16="http://schemas.microsoft.com/office/drawing/2014/main" id="{C422AE0A-9395-4077-8AF6-1DE715BCDE51}"/>
+              </a:ext>
+            </a:extLst>
+          </p:cNvPr>
+          <p:cNvSpPr/>
+          <p:nvPr/>
+        </p:nvSpPr>
+        <p:spPr>
+          <a:xfrm>
+            <a:off x="6000750" y="4371975"/>
+            <a:ext cx="1038225" cy="419100"/>
+          </a:xfrm>
+          <a:prstGeom prst="rect">
+            <a:avLst/>
+          </a:prstGeom>
+          <a:solidFill>
+            <a:schemeClr val="bg1"/>
+          </a:solidFill>
+          <a:ln>
+            <a:solidFill>
+              <a:schemeClr val="bg1"/>
+            </a:solidFill>
+          </a:ln>
+        </p:spPr>
+        <p:style>
+          <a:lnRef idx="2">
+            <a:schemeClr val="accent1">
+              <a:shade val="50000"/>
+            </a:schemeClr>
+          </a:lnRef>
+          <a:fillRef idx="1">
+            <a:schemeClr val="accent1"/>
+          </a:fillRef>
+          <a:effectRef idx="0">
+            <a:schemeClr val="accent1"/>
+          </a:effectRef>
+          <a:fontRef idx="minor">
+            <a:schemeClr val="lt1"/>
+          </a:fontRef>
+        </p:style>
+        <p:txBody>
+          <a:bodyPr rtlCol="0" anchor="ctr"/>
+          <a:lstStyle/>
+          <a:p>
+            <a:pPr algn="ctr"/>
+            <a:endParaRPr lang="en-US"/>
+          </a:p>
+        </p:txBody>
+      </p:sp>
+      <p:sp>
+        <p:nvSpPr>
+          <p:cNvPr id="8" name="Rectangle 7">
+            <a:extLst>
+              <a:ext uri="{FF2B5EF4-FFF2-40B4-BE49-F238E27FC236}">
+                <a16:creationId xmlns:a16="http://schemas.microsoft.com/office/drawing/2014/main" id="{9328ECDC-1F8F-44AA-9560-F98778710277}"/>
+              </a:ext>
+            </a:extLst>
+          </p:cNvPr>
+          <p:cNvSpPr/>
+          <p:nvPr/>
+        </p:nvSpPr>
+        <p:spPr>
+          <a:xfrm>
+            <a:off x="4705351" y="1333500"/>
+            <a:ext cx="247650" cy="419100"/>
+          </a:xfrm>
+          <a:prstGeom prst="rect">
+            <a:avLst/>
+          </a:prstGeom>
+          <a:solidFill>
+            <a:schemeClr val="bg1"/>
+          </a:solidFill>
+          <a:ln>
+            <a:solidFill>
+              <a:schemeClr val="bg1"/>
+            </a:solidFill>
+          </a:ln>
+        </p:spPr>
+        <p:style>
+          <a:lnRef idx="2">
+            <a:schemeClr val="accent1">
+              <a:shade val="50000"/>
+            </a:schemeClr>
+          </a:lnRef>
+          <a:fillRef idx="1">
+            <a:schemeClr val="accent1"/>
+          </a:fillRef>
+          <a:effectRef idx="0">
+            <a:schemeClr val="accent1"/>
+          </a:effectRef>
+          <a:fontRef idx="minor">
+            <a:schemeClr val="lt1"/>
+          </a:fontRef>
+        </p:style>
+        <p:txBody>
+          <a:bodyPr rtlCol="0" anchor="ctr"/>
+          <a:lstStyle/>
+          <a:p>
+            <a:pPr algn="ctr"/>
+            <a:endParaRPr lang="en-US"/>
+          </a:p>
+        </p:txBody>
+      </p:sp>
+    </p:spTree>
+    <p:extLst>
+      <p:ext uri="{BB962C8B-B14F-4D97-AF65-F5344CB8AC3E}">
+        <p14:creationId xmlns:p14="http://schemas.microsoft.com/office/powerpoint/2010/main" val="1066394301"/>
       </p:ext>
     </p:extLst>
   </p:cSld>

</xml_diff>

<commit_message>
add age sampling module,
</commit_message>
<xml_diff>
--- a/SALT_icons.pptx
+++ b/SALT_icons.pptx
@@ -5,7 +5,7 @@
     <p:sldMasterId id="2147483648" r:id="rId1"/>
   </p:sldMasterIdLst>
   <p:notesMasterIdLst>
-    <p:notesMasterId r:id="rId12"/>
+    <p:notesMasterId r:id="rId13"/>
   </p:notesMasterIdLst>
   <p:sldIdLst>
     <p:sldId id="256" r:id="rId2"/>
@@ -18,6 +18,7 @@
     <p:sldId id="263" r:id="rId9"/>
     <p:sldId id="264" r:id="rId10"/>
     <p:sldId id="265" r:id="rId11"/>
+    <p:sldId id="266" r:id="rId12"/>
   </p:sldIdLst>
   <p:sldSz cx="12192000" cy="6858000"/>
   <p:notesSz cx="6858000" cy="9144000"/>
@@ -206,7 +207,7 @@
           <a:p>
             <a:fld id="{25BA9636-C812-4FA3-A200-DB6EEA015C62}" type="datetimeFigureOut">
               <a:rPr lang="en-US" smtClean="0"/>
-              <a:t>12/15/2025</a:t>
+              <a:t>3/27/2026</a:t>
             </a:fld>
             <a:endParaRPr lang="en-US"/>
           </a:p>
@@ -704,7 +705,7 @@
           <a:p>
             <a:fld id="{A52A0AC6-1FC2-46EF-B96C-23ED3DABE568}" type="datetimeFigureOut">
               <a:rPr lang="en-US" smtClean="0"/>
-              <a:t>12/15/2025</a:t>
+              <a:t>3/27/2026</a:t>
             </a:fld>
             <a:endParaRPr lang="en-US"/>
           </a:p>
@@ -902,7 +903,7 @@
           <a:p>
             <a:fld id="{A52A0AC6-1FC2-46EF-B96C-23ED3DABE568}" type="datetimeFigureOut">
               <a:rPr lang="en-US" smtClean="0"/>
-              <a:t>12/15/2025</a:t>
+              <a:t>3/27/2026</a:t>
             </a:fld>
             <a:endParaRPr lang="en-US"/>
           </a:p>
@@ -1110,7 +1111,7 @@
           <a:p>
             <a:fld id="{A52A0AC6-1FC2-46EF-B96C-23ED3DABE568}" type="datetimeFigureOut">
               <a:rPr lang="en-US" smtClean="0"/>
-              <a:t>12/15/2025</a:t>
+              <a:t>3/27/2026</a:t>
             </a:fld>
             <a:endParaRPr lang="en-US"/>
           </a:p>
@@ -1308,7 +1309,7 @@
           <a:p>
             <a:fld id="{A52A0AC6-1FC2-46EF-B96C-23ED3DABE568}" type="datetimeFigureOut">
               <a:rPr lang="en-US" smtClean="0"/>
-              <a:t>12/15/2025</a:t>
+              <a:t>3/27/2026</a:t>
             </a:fld>
             <a:endParaRPr lang="en-US"/>
           </a:p>
@@ -1583,7 +1584,7 @@
           <a:p>
             <a:fld id="{A52A0AC6-1FC2-46EF-B96C-23ED3DABE568}" type="datetimeFigureOut">
               <a:rPr lang="en-US" smtClean="0"/>
-              <a:t>12/15/2025</a:t>
+              <a:t>3/27/2026</a:t>
             </a:fld>
             <a:endParaRPr lang="en-US"/>
           </a:p>
@@ -1848,7 +1849,7 @@
           <a:p>
             <a:fld id="{A52A0AC6-1FC2-46EF-B96C-23ED3DABE568}" type="datetimeFigureOut">
               <a:rPr lang="en-US" smtClean="0"/>
-              <a:t>12/15/2025</a:t>
+              <a:t>3/27/2026</a:t>
             </a:fld>
             <a:endParaRPr lang="en-US"/>
           </a:p>
@@ -2260,7 +2261,7 @@
           <a:p>
             <a:fld id="{A52A0AC6-1FC2-46EF-B96C-23ED3DABE568}" type="datetimeFigureOut">
               <a:rPr lang="en-US" smtClean="0"/>
-              <a:t>12/15/2025</a:t>
+              <a:t>3/27/2026</a:t>
             </a:fld>
             <a:endParaRPr lang="en-US"/>
           </a:p>
@@ -2401,7 +2402,7 @@
           <a:p>
             <a:fld id="{A52A0AC6-1FC2-46EF-B96C-23ED3DABE568}" type="datetimeFigureOut">
               <a:rPr lang="en-US" smtClean="0"/>
-              <a:t>12/15/2025</a:t>
+              <a:t>3/27/2026</a:t>
             </a:fld>
             <a:endParaRPr lang="en-US"/>
           </a:p>
@@ -2514,7 +2515,7 @@
           <a:p>
             <a:fld id="{A52A0AC6-1FC2-46EF-B96C-23ED3DABE568}" type="datetimeFigureOut">
               <a:rPr lang="en-US" smtClean="0"/>
-              <a:t>12/15/2025</a:t>
+              <a:t>3/27/2026</a:t>
             </a:fld>
             <a:endParaRPr lang="en-US"/>
           </a:p>
@@ -2825,7 +2826,7 @@
           <a:p>
             <a:fld id="{A52A0AC6-1FC2-46EF-B96C-23ED3DABE568}" type="datetimeFigureOut">
               <a:rPr lang="en-US" smtClean="0"/>
-              <a:t>12/15/2025</a:t>
+              <a:t>3/27/2026</a:t>
             </a:fld>
             <a:endParaRPr lang="en-US"/>
           </a:p>
@@ -3113,7 +3114,7 @@
           <a:p>
             <a:fld id="{A52A0AC6-1FC2-46EF-B96C-23ED3DABE568}" type="datetimeFigureOut">
               <a:rPr lang="en-US" smtClean="0"/>
-              <a:t>12/15/2025</a:t>
+              <a:t>3/27/2026</a:t>
             </a:fld>
             <a:endParaRPr lang="en-US"/>
           </a:p>
@@ -3354,7 +3355,7 @@
           <a:p>
             <a:fld id="{A52A0AC6-1FC2-46EF-B96C-23ED3DABE568}" type="datetimeFigureOut">
               <a:rPr lang="en-US" smtClean="0"/>
-              <a:t>12/15/2025</a:t>
+              <a:t>3/27/2026</a:t>
             </a:fld>
             <a:endParaRPr lang="en-US"/>
           </a:p>
@@ -4351,6 +4352,72 @@
     <p:extLst>
       <p:ext uri="{BB962C8B-B14F-4D97-AF65-F5344CB8AC3E}">
         <p14:creationId xmlns:p14="http://schemas.microsoft.com/office/powerpoint/2010/main" val="4120203952"/>
+      </p:ext>
+    </p:extLst>
+  </p:cSld>
+  <p:clrMapOvr>
+    <a:masterClrMapping/>
+  </p:clrMapOvr>
+</p:sld>
+</file>
+
+<file path=ppt/slides/slide11.xml><?xml version="1.0" encoding="utf-8"?>
+<p:sld xmlns:a="http://schemas.openxmlformats.org/drawingml/2006/main" xmlns:r="http://schemas.openxmlformats.org/officeDocument/2006/relationships" xmlns:p="http://schemas.openxmlformats.org/presentationml/2006/main">
+  <p:cSld>
+    <p:spTree>
+      <p:nvGrpSpPr>
+        <p:cNvPr id="1" name=""/>
+        <p:cNvGrpSpPr/>
+        <p:nvPr/>
+      </p:nvGrpSpPr>
+      <p:grpSpPr>
+        <a:xfrm>
+          <a:off x="0" y="0"/>
+          <a:ext cx="0" cy="0"/>
+          <a:chOff x="0" y="0"/>
+          <a:chExt cx="0" cy="0"/>
+        </a:xfrm>
+      </p:grpSpPr>
+      <p:pic>
+        <p:nvPicPr>
+          <p:cNvPr id="7" name="Picture 6">
+            <a:extLst>
+              <a:ext uri="{FF2B5EF4-FFF2-40B4-BE49-F238E27FC236}">
+                <a16:creationId xmlns:a16="http://schemas.microsoft.com/office/drawing/2014/main" id="{331F2507-DFE4-4392-AD77-05F990930B52}"/>
+              </a:ext>
+            </a:extLst>
+          </p:cNvPr>
+          <p:cNvPicPr>
+            <a:picLocks/>
+          </p:cNvPicPr>
+          <p:nvPr/>
+        </p:nvPicPr>
+        <p:blipFill>
+          <a:blip r:embed="rId2">
+            <a:extLst>
+              <a:ext uri="{28A0092B-C50C-407E-A947-70E740481C1C}">
+                <a14:useLocalDpi xmlns:a14="http://schemas.microsoft.com/office/drawing/2010/main" val="0"/>
+              </a:ext>
+            </a:extLst>
+          </a:blip>
+          <a:stretch>
+            <a:fillRect/>
+          </a:stretch>
+        </p:blipFill>
+        <p:spPr>
+          <a:xfrm>
+            <a:off x="1428749" y="742949"/>
+            <a:ext cx="8867775" cy="5191125"/>
+          </a:xfrm>
+          <a:prstGeom prst="rect">
+            <a:avLst/>
+          </a:prstGeom>
+        </p:spPr>
+      </p:pic>
+    </p:spTree>
+    <p:extLst>
+      <p:ext uri="{BB962C8B-B14F-4D97-AF65-F5344CB8AC3E}">
+        <p14:creationId xmlns:p14="http://schemas.microsoft.com/office/powerpoint/2010/main" val="3464026593"/>
       </p:ext>
     </p:extLst>
   </p:cSld>

</xml_diff>